<commit_message>
VisEssay: no public download (authors share on request)
</commit_message>
<xml_diff>
--- a/AI_Seminar_Meeting2.pptx
+++ b/AI_Seminar_Meeting2.pptx
@@ -955,7 +955,7 @@
           </a:p>
           <a:p>
             <a:r>
-              <a:t>- Essays: no. VisEssay has more than 13,000 graded handwritten essays, but I found no way to download it. BRESSAY has</a:t>
+              <a:t>- Essays: no. VisEssay has more than 13,000 graded handwritten essays, but there is no public download (the authors share it on request). BRESSAY has</a:t>
             </a:r>
           </a:p>
           <a:p>
@@ -28327,7 +28327,7 @@
                             <a:srgbClr val="2B2C30"/>
                           </a:solidFill>
                         </a:rPr>
-                        <a:t> not downloadable; </a:t>
+                        <a:t> no public download; </a:t>
                       </a:r>
                       <a:r>
                         <a:rPr sz="1200" b="0">

</xml_diff>

<commit_message>
Slide 5: drop 'for you' from titles
</commit_message>
<xml_diff>
--- a/AI_Seminar_Meeting2.pptx
+++ b/AI_Seminar_Meeting2.pptx
@@ -31728,7 +31728,7 @@
           <a:lstStyle/>
           <a:p>
             <a:r>
-              <a:t>Next steps and questions for you</a:t>
+              <a:t>Next steps and questions</a:t>
             </a:r>
           </a:p>
         </p:txBody>
@@ -32343,7 +32343,7 @@
                   <a:srgbClr val="046E98"/>
                 </a:solidFill>
               </a:rPr>
-              <a:t>QUESTIONS FOR YOU</a:t>
+              <a:t>QUESTIONS</a:t>
             </a:r>
           </a:p>
         </p:txBody>

</xml_diff>